<commit_message>
docs: investor pitch deck, testing chapter and infra guides
Add AIAAS_Investor_Pitch.pptx + presenter guide, LLD 11_How_We_Test, cloud/networking, infra and realtime guides. Update arch overview deck, drop stale HTML export and typo file, ignore presentation assets.
</commit_message>
<xml_diff>
--- a/AIAAS_Architecture_Technical_Overview.pptx
+++ b/AIAAS_Architecture_Technical_Overview.pptx
@@ -21,6 +21,8 @@
     <p:sldId id="269" r:id="rId21"/>
     <p:sldId id="270" r:id="rId22"/>
     <p:sldId id="271" r:id="rId23"/>
+    <p:sldId id="272" r:id="rId24"/>
+    <p:sldId id="273" r:id="rId25"/>
   </p:sldIdLst>
   <p:sldSz cx="12191695" cy="6858000" type="screen4x3"/>
   <p:notesSz cx="6858000" cy="9144000"/>
@@ -1391,7 +1393,7 @@
           <a:lstStyle/>
           <a:p>
             <a:r>
-              <a:t>Welcome everyone. This presentation provides an illustrated, visual-first technical tour of the AIAAS architecture, core engineering decisions, and agentic dynamics.</a:t>
+              <a:t>Welcome. Today we present the architecture, core engineering decisions, low-level design patterns, and institutional solution memory of the AIAAS platform.</a:t>
             </a:r>
           </a:p>
         </p:txBody>
@@ -1531,7 +1533,7 @@
           <a:lstStyle/>
           <a:p>
             <a:r>
-              <a:t>Steerability gives human operators active oversight during long agent runs, preventing wasted tokens and drift.</a:t>
+              <a:t>When an engineer solves a problem in chat, AIAAS automatically extracts a structured Solution record into the organization's private FAISS index. Future queries search this index and cite proven fixes.</a:t>
             </a:r>
           </a:p>
         </p:txBody>
@@ -1601,7 +1603,7 @@
           <a:lstStyle/>
           <a:p>
             <a:r>
-              <a:t>Observability revolves around the Turn, not the Step. Models reason once per turn, so storing reasoning at the turn level preserves accurate semantic attribution.</a:t>
+              <a:t>Solutions are classified into static, version-dependent, and ephemeral claims. Staleness is computed at read-time, warning the model when dependencies may have drifted.</a:t>
             </a:r>
           </a:p>
         </p:txBody>
@@ -1671,7 +1673,7 @@
           <a:lstStyle/>
           <a:p>
             <a:r>
-              <a:t>By evaluating agents through the exact same runtime entry point and using hermetic mock environments, AIAAS avoids synthetic evaluation drift.</a:t>
+              <a:t>Every solution belongs to exactly one organization. Queries execute through visible_solutions() with live membership verification. Foreign IDs return 404 to prevent probing.</a:t>
             </a:r>
           </a:p>
         </p:txBody>
@@ -1741,7 +1743,7 @@
           <a:lstStyle/>
           <a:p>
             <a:r>
-              <a:t>These principles summarize the engineering discipline of AIAAS: bound all resources, enforce structural role safety, ensure idempotence, and trace cognition.</a:t>
+              <a:t>Steerability gives human operators active oversight during long agent runs, preventing wasted tokens and drift.</a:t>
             </a:r>
           </a:p>
         </p:txBody>
@@ -1811,7 +1813,7 @@
           <a:lstStyle/>
           <a:p>
             <a:r>
-              <a:t>Transparent engineering limits: current deployment on a 1GB EC2 instance transitions to managed databases and Redis-backed state for horizontal scale.</a:t>
+              <a:t>Observability revolves around the Turn, not the Step. Models reason once per turn, so storing reasoning at the turn level preserves accurate semantic attribution.</a:t>
             </a:r>
           </a:p>
         </p:txBody>
@@ -1837,6 +1839,146 @@
 </file>
 
 <file path=ppt/notesSlides/notesSlide16.xml><?xml version="1.0" encoding="utf-8"?>
+<p:notes xmlns:a="http://schemas.openxmlformats.org/drawingml/2006/main" xmlns:p="http://schemas.openxmlformats.org/presentationml/2006/main" xmlns:r="http://schemas.openxmlformats.org/officeDocument/2006/relationships">
+  <p:cSld>
+    <p:spTree>
+      <p:nvGrpSpPr>
+        <p:cNvPr id="1" name=""/>
+        <p:cNvGrpSpPr/>
+        <p:nvPr/>
+      </p:nvGrpSpPr>
+      <p:grpSpPr>
+        <a:xfrm>
+          <a:off x="0" y="0"/>
+          <a:ext cx="0" cy="0"/>
+          <a:chOff x="0" y="0"/>
+          <a:chExt cx="0" cy="0"/>
+        </a:xfrm>
+      </p:grpSpPr>
+      <p:sp>
+        <p:nvSpPr>
+          <p:cNvPr id="2" name="Slide Image Placeholder 1"/>
+          <p:cNvSpPr>
+            <a:spLocks noGrp="1"/>
+          </p:cNvSpPr>
+          <p:nvPr>
+            <p:ph type="sldImg" idx="2"/>
+          </p:nvPr>
+        </p:nvSpPr>
+        <p:spPr/>
+      </p:sp>
+      <p:sp>
+        <p:nvSpPr>
+          <p:cNvPr id="3" name="Notes Placeholder 2"/>
+          <p:cNvSpPr>
+            <a:spLocks noGrp="1"/>
+          </p:cNvSpPr>
+          <p:nvPr>
+            <p:ph type="body" idx="3" sz="quarter"/>
+          </p:nvPr>
+        </p:nvSpPr>
+        <p:spPr/>
+        <p:txBody>
+          <a:bodyPr/>
+          <a:lstStyle/>
+          <a:p>
+            <a:r>
+              <a:t>By evaluating agents through the exact same runtime entry point and using hermetic mock environments, AIAAS avoids synthetic evaluation drift.</a:t>
+            </a:r>
+          </a:p>
+        </p:txBody>
+      </p:sp>
+      <p:sp>
+        <p:nvSpPr>
+          <p:cNvPr id="4" name="Slide Number Placeholder 3"/>
+          <p:cNvSpPr>
+            <a:spLocks noGrp="1"/>
+          </p:cNvSpPr>
+          <p:nvPr>
+            <p:ph type="sldNum" idx="5" sz="quarter"/>
+          </p:nvPr>
+        </p:nvSpPr>
+        <p:spPr/>
+      </p:sp>
+    </p:spTree>
+  </p:cSld>
+  <p:clrMapOvr>
+    <a:masterClrMapping/>
+  </p:clrMapOvr>
+</p:notes>
+</file>
+
+<file path=ppt/notesSlides/notesSlide17.xml><?xml version="1.0" encoding="utf-8"?>
+<p:notes xmlns:a="http://schemas.openxmlformats.org/drawingml/2006/main" xmlns:p="http://schemas.openxmlformats.org/presentationml/2006/main" xmlns:r="http://schemas.openxmlformats.org/officeDocument/2006/relationships">
+  <p:cSld>
+    <p:spTree>
+      <p:nvGrpSpPr>
+        <p:cNvPr id="1" name=""/>
+        <p:cNvGrpSpPr/>
+        <p:nvPr/>
+      </p:nvGrpSpPr>
+      <p:grpSpPr>
+        <a:xfrm>
+          <a:off x="0" y="0"/>
+          <a:ext cx="0" cy="0"/>
+          <a:chOff x="0" y="0"/>
+          <a:chExt cx="0" cy="0"/>
+        </a:xfrm>
+      </p:grpSpPr>
+      <p:sp>
+        <p:nvSpPr>
+          <p:cNvPr id="2" name="Slide Image Placeholder 1"/>
+          <p:cNvSpPr>
+            <a:spLocks noGrp="1"/>
+          </p:cNvSpPr>
+          <p:nvPr>
+            <p:ph type="sldImg" idx="2"/>
+          </p:nvPr>
+        </p:nvSpPr>
+        <p:spPr/>
+      </p:sp>
+      <p:sp>
+        <p:nvSpPr>
+          <p:cNvPr id="3" name="Notes Placeholder 2"/>
+          <p:cNvSpPr>
+            <a:spLocks noGrp="1"/>
+          </p:cNvSpPr>
+          <p:nvPr>
+            <p:ph type="body" idx="3" sz="quarter"/>
+          </p:nvPr>
+        </p:nvSpPr>
+        <p:spPr/>
+        <p:txBody>
+          <a:bodyPr/>
+          <a:lstStyle/>
+          <a:p>
+            <a:r>
+              <a:t>These principles summarize the engineering discipline of AIAAS: bound all resources, enforce structural role safety, ensure idempotence, capture institutional memory, and trace cognition.</a:t>
+            </a:r>
+          </a:p>
+        </p:txBody>
+      </p:sp>
+      <p:sp>
+        <p:nvSpPr>
+          <p:cNvPr id="4" name="Slide Number Placeholder 3"/>
+          <p:cNvSpPr>
+            <a:spLocks noGrp="1"/>
+          </p:cNvSpPr>
+          <p:nvPr>
+            <p:ph type="sldNum" idx="5" sz="quarter"/>
+          </p:nvPr>
+        </p:nvSpPr>
+        <p:spPr/>
+      </p:sp>
+    </p:spTree>
+  </p:cSld>
+  <p:clrMapOvr>
+    <a:masterClrMapping/>
+  </p:clrMapOvr>
+</p:notes>
+</file>
+
+<file path=ppt/notesSlides/notesSlide18.xml><?xml version="1.0" encoding="utf-8"?>
 <p:notes xmlns:a="http://schemas.openxmlformats.org/drawingml/2006/main" xmlns:p="http://schemas.openxmlformats.org/presentationml/2006/main" xmlns:r="http://schemas.openxmlformats.org/officeDocument/2006/relationships">
   <p:cSld>
     <p:spTree>
@@ -5562,7 +5704,7 @@
                 </a:solidFill>
                 <a:latin typeface="Arial"/>
               </a:rPr>
-              <a:t>Visual Technical Tour: Engineering Decisions, Safe Orchestration, and Qualitative Analysis</a:t>
+              <a:t>Engineering Decisions, LLD Patterns, and Institutional Memory in a Production Agentic System</a:t>
             </a:r>
           </a:p>
         </p:txBody>
@@ -5908,7 +6050,7 @@
                 </a:solidFill>
                 <a:latin typeface="Arial"/>
               </a:rPr>
-              <a:t>Qualitative Analysis: Mid-Flight Steerability</a:t>
+              <a:t>Org-Scoped Solution Memory</a:t>
             </a:r>
           </a:p>
         </p:txBody>
@@ -6011,7 +6153,7 @@
                 </a:solidFill>
                 <a:latin typeface="Arial"/>
               </a:rPr>
-              <a:t>Eliminating fire-and-forget black boxes: Real-time operator guidance during live runs</a:t>
+              <a:t>'Someone here already solved this': Automatic capture and reuse of organizational fixes</a:t>
             </a:r>
           </a:p>
         </p:txBody>
@@ -6150,7 +6292,7 @@
                 </a:solidFill>
                 <a:latin typeface="Arial"/>
               </a:rPr>
-              <a:t>Qualitative Analysis: Relational Observability</a:t>
+              <a:t>Dynamic Freshness &amp; Staleness Engine</a:t>
             </a:r>
           </a:p>
         </p:txBody>
@@ -6253,7 +6395,7 @@
                 </a:solidFill>
                 <a:latin typeface="Arial"/>
               </a:rPr>
-              <a:t>Structuring execution traces around cognitive turns rather than inferred DAG steps</a:t>
+              <a:t>Evaluating claim durability at read-time to prevent outdated documentation hallucination</a:t>
             </a:r>
           </a:p>
         </p:txBody>
@@ -6392,7 +6534,7 @@
                 </a:solidFill>
                 <a:latin typeface="Arial"/>
               </a:rPr>
-              <a:t>Qualitative Analysis: Evaluation Engine</a:t>
+              <a:t>Multi-Tenancy &amp; Zero-Leak Org Isolation</a:t>
             </a:r>
           </a:p>
         </p:txBody>
@@ -6495,7 +6637,7 @@
                 </a:solidFill>
                 <a:latin typeface="Arial"/>
               </a:rPr>
-              <a:t>Hermetic mock testing worlds, unoverwritable auto-grades, and pre-deploy CI gates</a:t>
+              <a:t>Hardware and row-level separation guaranteeing organizational data confidentiality</a:t>
             </a:r>
           </a:p>
         </p:txBody>
@@ -6634,7 +6776,7 @@
                 </a:solidFill>
                 <a:latin typeface="Arial"/>
               </a:rPr>
-              <a:t>The Five Pillars of Industrial Agentic Engineering</a:t>
+              <a:t>Qualitative Analysis: Mid-Flight Steerability</a:t>
             </a:r>
           </a:p>
         </p:txBody>
@@ -6737,7 +6879,7 @@
                 </a:solidFill>
                 <a:latin typeface="Arial"/>
               </a:rPr>
-              <a:t>Proven architectural principles separating toy agent wrappers from enterprise automation</a:t>
+              <a:t>Eliminating fire-and-forget black boxes: Real-time operator guidance during live runs</a:t>
             </a:r>
           </a:p>
         </p:txBody>
@@ -6876,7 +7018,7 @@
                 </a:solidFill>
                 <a:latin typeface="Arial"/>
               </a:rPr>
-              <a:t>Architectural Bottlenecks &amp; Evolution Roadmap</a:t>
+              <a:t>Qualitative Analysis: Relational Observability</a:t>
             </a:r>
           </a:p>
         </p:txBody>
@@ -6925,487 +7067,68 @@
           </a:p>
         </p:txBody>
       </p:sp>
-      <p:graphicFrame>
-        <p:nvGraphicFramePr>
-          <p:cNvPr id="5" name="Table 4"/>
-          <p:cNvGraphicFramePr>
-            <a:graphicFrameLocks noGrp="1"/>
-          </p:cNvGraphicFramePr>
+      <p:pic>
+        <p:nvPicPr>
+          <p:cNvPr id="5" name="Picture 4" descr="image.png"/>
+          <p:cNvPicPr>
+            <a:picLocks noChangeAspect="1"/>
+          </p:cNvPicPr>
           <p:nvPr/>
-        </p:nvGraphicFramePr>
-        <p:xfrm>
-          <a:off x="640080" y="1691640"/>
-          <a:ext cx="10911535" cy="2103120"/>
-        </p:xfrm>
-        <a:graphic>
-          <a:graphicData uri="http://schemas.openxmlformats.org/drawingml/2006/table">
-            <a:tbl>
-              <a:tblPr firstRow="0" bandRow="0">
-                <a:tableStyleId>{5C22544A-7EE6-4342-B048-85BDC9FD1C3A}</a:tableStyleId>
-              </a:tblPr>
-              <a:tblGrid>
-                <a:gridCol w="2727883"/>
-                <a:gridCol w="2727883"/>
-                <a:gridCol w="2727883"/>
-                <a:gridCol w="2727886"/>
-              </a:tblGrid>
-              <a:tr h="420624">
-                <a:tc>
-                  <a:txBody>
-                    <a:bodyPr wrap="square"/>
-                    <a:lstStyle/>
-                    <a:p>
-                      <a:r>
-                        <a:rPr sz="1400" b="1" i="0">
-                          <a:solidFill>
-                            <a:srgbClr val="FFFFFF"/>
-                          </a:solidFill>
-                          <a:latin typeface="Arial"/>
-                        </a:rPr>
-                        <a:t>Component</a:t>
-                      </a:r>
-                    </a:p>
-                  </a:txBody>
-                  <a:tcPr marL="109728" marR="109728" anchor="ctr">
-                    <a:solidFill>
-                      <a:srgbClr val="4A3AA7"/>
-                    </a:solidFill>
-                  </a:tcPr>
-                </a:tc>
-                <a:tc>
-                  <a:txBody>
-                    <a:bodyPr wrap="square"/>
-                    <a:lstStyle/>
-                    <a:p>
-                      <a:r>
-                        <a:rPr sz="1400" b="1" i="0">
-                          <a:solidFill>
-                            <a:srgbClr val="FFFFFF"/>
-                          </a:solidFill>
-                          <a:latin typeface="Arial"/>
-                        </a:rPr>
-                        <a:t>Current State</a:t>
-                      </a:r>
-                    </a:p>
-                  </a:txBody>
-                  <a:tcPr marL="109728" marR="109728" anchor="ctr">
-                    <a:solidFill>
-                      <a:srgbClr val="4A3AA7"/>
-                    </a:solidFill>
-                  </a:tcPr>
-                </a:tc>
-                <a:tc>
-                  <a:txBody>
-                    <a:bodyPr wrap="square"/>
-                    <a:lstStyle/>
-                    <a:p>
-                      <a:r>
-                        <a:rPr sz="1400" b="1" i="0">
-                          <a:solidFill>
-                            <a:srgbClr val="FFFFFF"/>
-                          </a:solidFill>
-                          <a:latin typeface="Arial"/>
-                        </a:rPr>
-                        <a:t>Bottleneck Cause</a:t>
-                      </a:r>
-                    </a:p>
-                  </a:txBody>
-                  <a:tcPr marL="109728" marR="109728" anchor="ctr">
-                    <a:solidFill>
-                      <a:srgbClr val="4A3AA7"/>
-                    </a:solidFill>
-                  </a:tcPr>
-                </a:tc>
-                <a:tc>
-                  <a:txBody>
-                    <a:bodyPr wrap="square"/>
-                    <a:lstStyle/>
-                    <a:p>
-                      <a:r>
-                        <a:rPr sz="1400" b="1" i="0">
-                          <a:solidFill>
-                            <a:srgbClr val="FFFFFF"/>
-                          </a:solidFill>
-                          <a:latin typeface="Arial"/>
-                        </a:rPr>
-                        <a:t>Target Architecture</a:t>
-                      </a:r>
-                    </a:p>
-                  </a:txBody>
-                  <a:tcPr marL="109728" marR="109728" anchor="ctr">
-                    <a:solidFill>
-                      <a:srgbClr val="4A3AA7"/>
-                    </a:solidFill>
-                  </a:tcPr>
-                </a:tc>
-              </a:tr>
-              <a:tr h="420624">
-                <a:tc>
-                  <a:txBody>
-                    <a:bodyPr wrap="square"/>
-                    <a:lstStyle/>
-                    <a:p>
-                      <a:r>
-                        <a:rPr sz="1400" b="0" i="0">
-                          <a:solidFill>
-                            <a:srgbClr val="17142B"/>
-                          </a:solidFill>
-                          <a:latin typeface="Arial"/>
-                        </a:rPr>
-                        <a:t>Run State</a:t>
-                      </a:r>
-                    </a:p>
-                  </a:txBody>
-                  <a:tcPr marL="109728" marR="109728" anchor="ctr">
-                    <a:solidFill>
-                      <a:srgbClr val="FFFFFF"/>
-                    </a:solidFill>
-                  </a:tcPr>
-                </a:tc>
-                <a:tc>
-                  <a:txBody>
-                    <a:bodyPr wrap="square"/>
-                    <a:lstStyle/>
-                    <a:p>
-                      <a:r>
-                        <a:rPr sz="1400" b="0" i="0">
-                          <a:solidFill>
-                            <a:srgbClr val="17142B"/>
-                          </a:solidFill>
-                          <a:latin typeface="Arial"/>
-                        </a:rPr>
-                        <a:t>In-Process Memory</a:t>
-                      </a:r>
-                    </a:p>
-                  </a:txBody>
-                  <a:tcPr marL="109728" marR="109728" anchor="ctr">
-                    <a:solidFill>
-                      <a:srgbClr val="FFFFFF"/>
-                    </a:solidFill>
-                  </a:tcPr>
-                </a:tc>
-                <a:tc>
-                  <a:txBody>
-                    <a:bodyPr wrap="square"/>
-                    <a:lstStyle/>
-                    <a:p>
-                      <a:r>
-                        <a:rPr sz="1400" b="0" i="0">
-                          <a:solidFill>
-                            <a:srgbClr val="17142B"/>
-                          </a:solidFill>
-                          <a:latin typeface="Arial"/>
-                        </a:rPr>
-                        <a:t>Single replica memory</a:t>
-                      </a:r>
-                    </a:p>
-                  </a:txBody>
-                  <a:tcPr marL="109728" marR="109728" anchor="ctr">
-                    <a:solidFill>
-                      <a:srgbClr val="FFFFFF"/>
-                    </a:solidFill>
-                  </a:tcPr>
-                </a:tc>
-                <a:tc>
-                  <a:txBody>
-                    <a:bodyPr wrap="square"/>
-                    <a:lstStyle/>
-                    <a:p>
-                      <a:r>
-                        <a:rPr sz="1400" b="0" i="0">
-                          <a:solidFill>
-                            <a:srgbClr val="17142B"/>
-                          </a:solidFill>
-                          <a:latin typeface="Arial"/>
-                        </a:rPr>
-                        <a:t>Redis Streams + PubSub</a:t>
-                      </a:r>
-                    </a:p>
-                  </a:txBody>
-                  <a:tcPr marL="109728" marR="109728" anchor="ctr">
-                    <a:solidFill>
-                      <a:srgbClr val="FFFFFF"/>
-                    </a:solidFill>
-                  </a:tcPr>
-                </a:tc>
-              </a:tr>
-              <a:tr h="420624">
-                <a:tc>
-                  <a:txBody>
-                    <a:bodyPr wrap="square"/>
-                    <a:lstStyle/>
-                    <a:p>
-                      <a:r>
-                        <a:rPr sz="1400" b="0" i="0">
-                          <a:solidFill>
-                            <a:srgbClr val="17142B"/>
-                          </a:solidFill>
-                          <a:latin typeface="Arial"/>
-                        </a:rPr>
-                        <a:t>Database</a:t>
-                      </a:r>
-                    </a:p>
-                  </a:txBody>
-                  <a:tcPr marL="109728" marR="109728" anchor="ctr">
-                    <a:solidFill>
-                      <a:srgbClr val="F1EFFA"/>
-                    </a:solidFill>
-                  </a:tcPr>
-                </a:tc>
-                <a:tc>
-                  <a:txBody>
-                    <a:bodyPr wrap="square"/>
-                    <a:lstStyle/>
-                    <a:p>
-                      <a:r>
-                        <a:rPr sz="1400" b="0" i="0">
-                          <a:solidFill>
-                            <a:srgbClr val="17142B"/>
-                          </a:solidFill>
-                          <a:latin typeface="Arial"/>
-                        </a:rPr>
-                        <a:t>Co-located Postgres</a:t>
-                      </a:r>
-                    </a:p>
-                  </a:txBody>
-                  <a:tcPr marL="109728" marR="109728" anchor="ctr">
-                    <a:solidFill>
-                      <a:srgbClr val="F1EFFA"/>
-                    </a:solidFill>
-                  </a:tcPr>
-                </a:tc>
-                <a:tc>
-                  <a:txBody>
-                    <a:bodyPr wrap="square"/>
-                    <a:lstStyle/>
-                    <a:p>
-                      <a:r>
-                        <a:rPr sz="1400" b="0" i="0">
-                          <a:solidFill>
-                            <a:srgbClr val="17142B"/>
-                          </a:solidFill>
-                          <a:latin typeface="Arial"/>
-                        </a:rPr>
-                        <a:t>Shares 913 MB RAM host</a:t>
-                      </a:r>
-                    </a:p>
-                  </a:txBody>
-                  <a:tcPr marL="109728" marR="109728" anchor="ctr">
-                    <a:solidFill>
-                      <a:srgbClr val="F1EFFA"/>
-                    </a:solidFill>
-                  </a:tcPr>
-                </a:tc>
-                <a:tc>
-                  <a:txBody>
-                    <a:bodyPr wrap="square"/>
-                    <a:lstStyle/>
-                    <a:p>
-                      <a:r>
-                        <a:rPr sz="1400" b="0" i="0">
-                          <a:solidFill>
-                            <a:srgbClr val="17142B"/>
-                          </a:solidFill>
-                          <a:latin typeface="Arial"/>
-                        </a:rPr>
-                        <a:t>AWS Managed RDS + PgBouncer</a:t>
-                      </a:r>
-                    </a:p>
-                  </a:txBody>
-                  <a:tcPr marL="109728" marR="109728" anchor="ctr">
-                    <a:solidFill>
-                      <a:srgbClr val="F1EFFA"/>
-                    </a:solidFill>
-                  </a:tcPr>
-                </a:tc>
-              </a:tr>
-              <a:tr h="420624">
-                <a:tc>
-                  <a:txBody>
-                    <a:bodyPr wrap="square"/>
-                    <a:lstStyle/>
-                    <a:p>
-                      <a:r>
-                        <a:rPr sz="1400" b="0" i="0">
-                          <a:solidFill>
-                            <a:srgbClr val="17142B"/>
-                          </a:solidFill>
-                          <a:latin typeface="Arial"/>
-                        </a:rPr>
-                        <a:t>Connectors</a:t>
-                      </a:r>
-                    </a:p>
-                  </a:txBody>
-                  <a:tcPr marL="109728" marR="109728" anchor="ctr">
-                    <a:solidFill>
-                      <a:srgbClr val="FFFFFF"/>
-                    </a:solidFill>
-                  </a:tcPr>
-                </a:tc>
-                <a:tc>
-                  <a:txBody>
-                    <a:bodyPr wrap="square"/>
-                    <a:lstStyle/>
-                    <a:p>
-                      <a:r>
-                        <a:rPr sz="1400" b="0" i="0">
-                          <a:solidFill>
-                            <a:srgbClr val="17142B"/>
-                          </a:solidFill>
-                          <a:latin typeface="Arial"/>
-                        </a:rPr>
-                        <a:t>Node.js Stdio</a:t>
-                      </a:r>
-                    </a:p>
-                  </a:txBody>
-                  <a:tcPr marL="109728" marR="109728" anchor="ctr">
-                    <a:solidFill>
-                      <a:srgbClr val="FFFFFF"/>
-                    </a:solidFill>
-                  </a:tcPr>
-                </a:tc>
-                <a:tc>
-                  <a:txBody>
-                    <a:bodyPr wrap="square"/>
-                    <a:lstStyle/>
-                    <a:p>
-                      <a:r>
-                        <a:rPr sz="1400" b="0" i="0">
-                          <a:solidFill>
-                            <a:srgbClr val="17142B"/>
-                          </a:solidFill>
-                          <a:latin typeface="Arial"/>
-                        </a:rPr>
-                        <a:t>70-150 MB per session</a:t>
-                      </a:r>
-                    </a:p>
-                  </a:txBody>
-                  <a:tcPr marL="109728" marR="109728" anchor="ctr">
-                    <a:solidFill>
-                      <a:srgbClr val="FFFFFF"/>
-                    </a:solidFill>
-                  </a:tcPr>
-                </a:tc>
-                <a:tc>
-                  <a:txBody>
-                    <a:bodyPr wrap="square"/>
-                    <a:lstStyle/>
-                    <a:p>
-                      <a:r>
-                        <a:rPr sz="1400" b="0" i="0">
-                          <a:solidFill>
-                            <a:srgbClr val="17142B"/>
-                          </a:solidFill>
-                          <a:latin typeface="Arial"/>
-                        </a:rPr>
-                        <a:t>Native REST API Connectors</a:t>
-                      </a:r>
-                    </a:p>
-                  </a:txBody>
-                  <a:tcPr marL="109728" marR="109728" anchor="ctr">
-                    <a:solidFill>
-                      <a:srgbClr val="FFFFFF"/>
-                    </a:solidFill>
-                  </a:tcPr>
-                </a:tc>
-              </a:tr>
-              <a:tr h="420624">
-                <a:tc>
-                  <a:txBody>
-                    <a:bodyPr wrap="square"/>
-                    <a:lstStyle/>
-                    <a:p>
-                      <a:r>
-                        <a:rPr sz="1400" b="0" i="0">
-                          <a:solidFill>
-                            <a:srgbClr val="17142B"/>
-                          </a:solidFill>
-                          <a:latin typeface="Arial"/>
-                        </a:rPr>
-                        <a:t>Pre-Model</a:t>
-                      </a:r>
-                    </a:p>
-                  </a:txBody>
-                  <a:tcPr marL="109728" marR="109728" anchor="ctr">
-                    <a:solidFill>
-                      <a:srgbClr val="F1EFFA"/>
-                    </a:solidFill>
-                  </a:tcPr>
-                </a:tc>
-                <a:tc>
-                  <a:txBody>
-                    <a:bodyPr wrap="square"/>
-                    <a:lstStyle/>
-                    <a:p>
-                      <a:r>
-                        <a:rPr sz="1400" b="0" i="0">
-                          <a:solidFill>
-                            <a:srgbClr val="17142B"/>
-                          </a:solidFill>
-                          <a:latin typeface="Arial"/>
-                        </a:rPr>
-                        <a:t>Sequential ORM</a:t>
-                      </a:r>
-                    </a:p>
-                  </a:txBody>
-                  <a:tcPr marL="109728" marR="109728" anchor="ctr">
-                    <a:solidFill>
-                      <a:srgbClr val="F1EFFA"/>
-                    </a:solidFill>
-                  </a:tcPr>
-                </a:tc>
-                <a:tc>
-                  <a:txBody>
-                    <a:bodyPr wrap="square"/>
-                    <a:lstStyle/>
-                    <a:p>
-                      <a:r>
-                        <a:rPr sz="1400" b="0" i="0">
-                          <a:solidFill>
-                            <a:srgbClr val="17142B"/>
-                          </a:solidFill>
-                          <a:latin typeface="Arial"/>
-                        </a:rPr>
-                        <a:t>20 async thread hops</a:t>
-                      </a:r>
-                    </a:p>
-                  </a:txBody>
-                  <a:tcPr marL="109728" marR="109728" anchor="ctr">
-                    <a:solidFill>
-                      <a:srgbClr val="F1EFFA"/>
-                    </a:solidFill>
-                  </a:tcPr>
-                </a:tc>
-                <a:tc>
-                  <a:txBody>
-                    <a:bodyPr wrap="square"/>
-                    <a:lstStyle/>
-                    <a:p>
-                      <a:r>
-                        <a:rPr sz="1400" b="0" i="0">
-                          <a:solidFill>
-                            <a:srgbClr val="17142B"/>
-                          </a:solidFill>
-                          <a:latin typeface="Arial"/>
-                        </a:rPr>
-                        <a:t>Batched Pre-Model Queries</a:t>
-                      </a:r>
-                    </a:p>
-                  </a:txBody>
-                  <a:tcPr marL="109728" marR="109728" anchor="ctr">
-                    <a:solidFill>
-                      <a:srgbClr val="F1EFFA"/>
-                    </a:solidFill>
-                  </a:tcPr>
-                </a:tc>
-              </a:tr>
-            </a:tbl>
-          </a:graphicData>
-        </a:graphic>
-      </p:graphicFrame>
+        </p:nvPicPr>
+        <p:blipFill>
+          <a:blip r:embed="rId2"/>
+          <a:stretch>
+            <a:fillRect/>
+          </a:stretch>
+        </p:blipFill>
+        <p:spPr>
+          <a:xfrm>
+            <a:off x="2298040" y="1691640"/>
+            <a:ext cx="7595615" cy="4069079"/>
+          </a:xfrm>
+          <a:prstGeom prst="rect">
+            <a:avLst/>
+          </a:prstGeom>
+        </p:spPr>
+      </p:pic>
       <p:sp>
         <p:nvSpPr>
           <p:cNvPr id="6" name="TextBox 5"/>
+          <p:cNvSpPr txBox="1"/>
+          <p:nvPr/>
+        </p:nvSpPr>
+        <p:spPr>
+          <a:xfrm>
+            <a:off x="640080" y="5833872"/>
+            <a:ext cx="10911535" cy="411480"/>
+          </a:xfrm>
+          <a:prstGeom prst="rect">
+            <a:avLst/>
+          </a:prstGeom>
+          <a:noFill/>
+        </p:spPr>
+        <p:txBody>
+          <a:bodyPr wrap="square" anchor="t" lIns="0" rIns="0" tIns="0" bIns="0">
+            <a:spAutoFit/>
+          </a:bodyPr>
+          <a:lstStyle/>
+          <a:p>
+            <a:pPr algn="ctr"/>
+            <a:r>
+              <a:rPr sz="1300" b="0" i="1">
+                <a:solidFill>
+                  <a:srgbClr val="5B5870"/>
+                </a:solidFill>
+                <a:latin typeface="Arial"/>
+              </a:rPr>
+              <a:t>Structuring execution traces around cognitive turns rather than inferred DAG steps</a:t>
+            </a:r>
+          </a:p>
+        </p:txBody>
+      </p:sp>
+      <p:sp>
+        <p:nvSpPr>
+          <p:cNvPr id="7" name="TextBox 6"/>
           <p:cNvSpPr txBox="1"/>
           <p:nvPr/>
         </p:nvSpPr>
@@ -7473,7 +7196,7 @@
         <p:spPr>
           <a:xfrm>
             <a:off x="0" y="0"/>
-            <a:ext cx="12191695" cy="6858000"/>
+            <a:ext cx="164592" cy="6858000"/>
           </a:xfrm>
           <a:prstGeom prst="rect">
             <a:avLst/>
@@ -7516,6 +7239,490 @@
         </p:nvSpPr>
         <p:spPr>
           <a:xfrm>
+            <a:off x="640080" y="457200"/>
+            <a:ext cx="10911535" cy="914400"/>
+          </a:xfrm>
+          <a:prstGeom prst="rect">
+            <a:avLst/>
+          </a:prstGeom>
+          <a:noFill/>
+        </p:spPr>
+        <p:txBody>
+          <a:bodyPr wrap="square" anchor="b" lIns="0" rIns="0" tIns="0" bIns="0">
+            <a:spAutoFit/>
+          </a:bodyPr>
+          <a:lstStyle/>
+          <a:p>
+            <a:r>
+              <a:rPr sz="3200" b="1" i="0">
+                <a:solidFill>
+                  <a:srgbClr val="17142B"/>
+                </a:solidFill>
+                <a:latin typeface="Arial"/>
+              </a:rPr>
+              <a:t>Qualitative Analysis: Evaluation Engine</a:t>
+            </a:r>
+          </a:p>
+        </p:txBody>
+      </p:sp>
+      <p:sp>
+        <p:nvSpPr>
+          <p:cNvPr id="4" name="Rectangle 3"/>
+          <p:cNvSpPr/>
+          <p:nvPr/>
+        </p:nvSpPr>
+        <p:spPr>
+          <a:xfrm>
+            <a:off x="640080" y="1444752"/>
+            <a:ext cx="822960" cy="50800"/>
+          </a:xfrm>
+          <a:prstGeom prst="rect">
+            <a:avLst/>
+          </a:prstGeom>
+          <a:solidFill>
+            <a:srgbClr val="4A3AA7"/>
+          </a:solidFill>
+          <a:ln>
+            <a:noFill/>
+          </a:ln>
+          <a:effectLst/>
+        </p:spPr>
+        <p:style>
+          <a:lnRef idx="1">
+            <a:schemeClr val="accent1"/>
+          </a:lnRef>
+          <a:fillRef idx="3">
+            <a:schemeClr val="accent1"/>
+          </a:fillRef>
+          <a:effectRef idx="2">
+            <a:schemeClr val="accent1"/>
+          </a:effectRef>
+          <a:fontRef idx="minor">
+            <a:schemeClr val="lt1"/>
+          </a:fontRef>
+        </p:style>
+        <p:txBody>
+          <a:bodyPr rtlCol="0" anchor="ctr"/>
+          <a:lstStyle/>
+          <a:p>
+            <a:pPr algn="ctr"/>
+          </a:p>
+        </p:txBody>
+      </p:sp>
+      <p:pic>
+        <p:nvPicPr>
+          <p:cNvPr id="5" name="Picture 4" descr="image.png"/>
+          <p:cNvPicPr>
+            <a:picLocks noChangeAspect="1"/>
+          </p:cNvPicPr>
+          <p:nvPr/>
+        </p:nvPicPr>
+        <p:blipFill>
+          <a:blip r:embed="rId2"/>
+          <a:stretch>
+            <a:fillRect/>
+          </a:stretch>
+        </p:blipFill>
+        <p:spPr>
+          <a:xfrm>
+            <a:off x="2298040" y="1691640"/>
+            <a:ext cx="7595615" cy="4069079"/>
+          </a:xfrm>
+          <a:prstGeom prst="rect">
+            <a:avLst/>
+          </a:prstGeom>
+        </p:spPr>
+      </p:pic>
+      <p:sp>
+        <p:nvSpPr>
+          <p:cNvPr id="6" name="TextBox 5"/>
+          <p:cNvSpPr txBox="1"/>
+          <p:nvPr/>
+        </p:nvSpPr>
+        <p:spPr>
+          <a:xfrm>
+            <a:off x="640080" y="5833872"/>
+            <a:ext cx="10911535" cy="411480"/>
+          </a:xfrm>
+          <a:prstGeom prst="rect">
+            <a:avLst/>
+          </a:prstGeom>
+          <a:noFill/>
+        </p:spPr>
+        <p:txBody>
+          <a:bodyPr wrap="square" anchor="t" lIns="0" rIns="0" tIns="0" bIns="0">
+            <a:spAutoFit/>
+          </a:bodyPr>
+          <a:lstStyle/>
+          <a:p>
+            <a:pPr algn="ctr"/>
+            <a:r>
+              <a:rPr sz="1300" b="0" i="1">
+                <a:solidFill>
+                  <a:srgbClr val="5B5870"/>
+                </a:solidFill>
+                <a:latin typeface="Arial"/>
+              </a:rPr>
+              <a:t>Hermetic mock testing worlds, unoverwritable auto-grades, and pre-deploy CI gates</a:t>
+            </a:r>
+          </a:p>
+        </p:txBody>
+      </p:sp>
+      <p:sp>
+        <p:nvSpPr>
+          <p:cNvPr id="7" name="TextBox 6"/>
+          <p:cNvSpPr txBox="1"/>
+          <p:nvPr/>
+        </p:nvSpPr>
+        <p:spPr>
+          <a:xfrm>
+            <a:off x="10637215" y="6400800"/>
+            <a:ext cx="914400" cy="274320"/>
+          </a:xfrm>
+          <a:prstGeom prst="rect">
+            <a:avLst/>
+          </a:prstGeom>
+          <a:noFill/>
+        </p:spPr>
+        <p:txBody>
+          <a:bodyPr wrap="square" anchor="ctr" lIns="0" rIns="0" tIns="0" bIns="0">
+            <a:spAutoFit/>
+          </a:bodyPr>
+          <a:lstStyle/>
+          <a:p>
+            <a:pPr algn="r"/>
+            <a:r>
+              <a:rPr sz="1100" b="0" i="0">
+                <a:solidFill>
+                  <a:srgbClr val="5B5870"/>
+                </a:solidFill>
+                <a:latin typeface="Arial"/>
+              </a:rPr>
+              <a:t>16</a:t>
+            </a:r>
+          </a:p>
+        </p:txBody>
+      </p:sp>
+    </p:spTree>
+  </p:cSld>
+  <p:clrMapOvr>
+    <a:masterClrMapping/>
+  </p:clrMapOvr>
+</p:sld>
+</file>
+
+<file path=ppt/slides/slide17.xml><?xml version="1.0" encoding="utf-8"?>
+<p:sld xmlns:a="http://schemas.openxmlformats.org/drawingml/2006/main" xmlns:p="http://schemas.openxmlformats.org/presentationml/2006/main" xmlns:r="http://schemas.openxmlformats.org/officeDocument/2006/relationships">
+  <p:cSld>
+    <p:bg>
+      <p:bgPr>
+        <a:solidFill>
+          <a:srgbClr val="FFFFFF"/>
+        </a:solidFill>
+        <a:effectLst/>
+      </p:bgPr>
+    </p:bg>
+    <p:spTree>
+      <p:nvGrpSpPr>
+        <p:cNvPr id="1" name=""/>
+        <p:cNvGrpSpPr/>
+        <p:nvPr/>
+      </p:nvGrpSpPr>
+      <p:grpSpPr/>
+      <p:sp>
+        <p:nvSpPr>
+          <p:cNvPr id="2" name="Rectangle 1"/>
+          <p:cNvSpPr/>
+          <p:nvPr/>
+        </p:nvSpPr>
+        <p:spPr>
+          <a:xfrm>
+            <a:off x="0" y="0"/>
+            <a:ext cx="164592" cy="6858000"/>
+          </a:xfrm>
+          <a:prstGeom prst="rect">
+            <a:avLst/>
+          </a:prstGeom>
+          <a:solidFill>
+            <a:srgbClr val="4A3AA7"/>
+          </a:solidFill>
+          <a:ln>
+            <a:noFill/>
+          </a:ln>
+          <a:effectLst/>
+        </p:spPr>
+        <p:style>
+          <a:lnRef idx="1">
+            <a:schemeClr val="accent1"/>
+          </a:lnRef>
+          <a:fillRef idx="3">
+            <a:schemeClr val="accent1"/>
+          </a:fillRef>
+          <a:effectRef idx="2">
+            <a:schemeClr val="accent1"/>
+          </a:effectRef>
+          <a:fontRef idx="minor">
+            <a:schemeClr val="lt1"/>
+          </a:fontRef>
+        </p:style>
+        <p:txBody>
+          <a:bodyPr rtlCol="0" anchor="ctr"/>
+          <a:lstStyle/>
+          <a:p>
+            <a:pPr algn="ctr"/>
+          </a:p>
+        </p:txBody>
+      </p:sp>
+      <p:sp>
+        <p:nvSpPr>
+          <p:cNvPr id="3" name="TextBox 2"/>
+          <p:cNvSpPr txBox="1"/>
+          <p:nvPr/>
+        </p:nvSpPr>
+        <p:spPr>
+          <a:xfrm>
+            <a:off x="640080" y="457200"/>
+            <a:ext cx="10911535" cy="914400"/>
+          </a:xfrm>
+          <a:prstGeom prst="rect">
+            <a:avLst/>
+          </a:prstGeom>
+          <a:noFill/>
+        </p:spPr>
+        <p:txBody>
+          <a:bodyPr wrap="square" anchor="b" lIns="0" rIns="0" tIns="0" bIns="0">
+            <a:spAutoFit/>
+          </a:bodyPr>
+          <a:lstStyle/>
+          <a:p>
+            <a:r>
+              <a:rPr sz="3200" b="1" i="0">
+                <a:solidFill>
+                  <a:srgbClr val="17142B"/>
+                </a:solidFill>
+                <a:latin typeface="Arial"/>
+              </a:rPr>
+              <a:t>Core Tenets of Industrial Agentic Engineering</a:t>
+            </a:r>
+          </a:p>
+        </p:txBody>
+      </p:sp>
+      <p:sp>
+        <p:nvSpPr>
+          <p:cNvPr id="4" name="Rectangle 3"/>
+          <p:cNvSpPr/>
+          <p:nvPr/>
+        </p:nvSpPr>
+        <p:spPr>
+          <a:xfrm>
+            <a:off x="640080" y="1444752"/>
+            <a:ext cx="822960" cy="50800"/>
+          </a:xfrm>
+          <a:prstGeom prst="rect">
+            <a:avLst/>
+          </a:prstGeom>
+          <a:solidFill>
+            <a:srgbClr val="4A3AA7"/>
+          </a:solidFill>
+          <a:ln>
+            <a:noFill/>
+          </a:ln>
+          <a:effectLst/>
+        </p:spPr>
+        <p:style>
+          <a:lnRef idx="1">
+            <a:schemeClr val="accent1"/>
+          </a:lnRef>
+          <a:fillRef idx="3">
+            <a:schemeClr val="accent1"/>
+          </a:fillRef>
+          <a:effectRef idx="2">
+            <a:schemeClr val="accent1"/>
+          </a:effectRef>
+          <a:fontRef idx="minor">
+            <a:schemeClr val="lt1"/>
+          </a:fontRef>
+        </p:style>
+        <p:txBody>
+          <a:bodyPr rtlCol="0" anchor="ctr"/>
+          <a:lstStyle/>
+          <a:p>
+            <a:pPr algn="ctr"/>
+          </a:p>
+        </p:txBody>
+      </p:sp>
+      <p:pic>
+        <p:nvPicPr>
+          <p:cNvPr id="5" name="Picture 4" descr="image.png"/>
+          <p:cNvPicPr>
+            <a:picLocks noChangeAspect="1"/>
+          </p:cNvPicPr>
+          <p:nvPr/>
+        </p:nvPicPr>
+        <p:blipFill>
+          <a:blip r:embed="rId2"/>
+          <a:stretch>
+            <a:fillRect/>
+          </a:stretch>
+        </p:blipFill>
+        <p:spPr>
+          <a:xfrm>
+            <a:off x="2298040" y="1691640"/>
+            <a:ext cx="7595615" cy="4069079"/>
+          </a:xfrm>
+          <a:prstGeom prst="rect">
+            <a:avLst/>
+          </a:prstGeom>
+        </p:spPr>
+      </p:pic>
+      <p:sp>
+        <p:nvSpPr>
+          <p:cNvPr id="6" name="TextBox 5"/>
+          <p:cNvSpPr txBox="1"/>
+          <p:nvPr/>
+        </p:nvSpPr>
+        <p:spPr>
+          <a:xfrm>
+            <a:off x="640080" y="5833872"/>
+            <a:ext cx="10911535" cy="411480"/>
+          </a:xfrm>
+          <a:prstGeom prst="rect">
+            <a:avLst/>
+          </a:prstGeom>
+          <a:noFill/>
+        </p:spPr>
+        <p:txBody>
+          <a:bodyPr wrap="square" anchor="t" lIns="0" rIns="0" tIns="0" bIns="0">
+            <a:spAutoFit/>
+          </a:bodyPr>
+          <a:lstStyle/>
+          <a:p>
+            <a:pPr algn="ctr"/>
+            <a:r>
+              <a:rPr sz="1300" b="0" i="1">
+                <a:solidFill>
+                  <a:srgbClr val="5B5870"/>
+                </a:solidFill>
+                <a:latin typeface="Arial"/>
+              </a:rPr>
+              <a:t>Proven architectural principles separating toy agent wrappers from enterprise automation</a:t>
+            </a:r>
+          </a:p>
+        </p:txBody>
+      </p:sp>
+      <p:sp>
+        <p:nvSpPr>
+          <p:cNvPr id="7" name="TextBox 6"/>
+          <p:cNvSpPr txBox="1"/>
+          <p:nvPr/>
+        </p:nvSpPr>
+        <p:spPr>
+          <a:xfrm>
+            <a:off x="10637215" y="6400800"/>
+            <a:ext cx="914400" cy="274320"/>
+          </a:xfrm>
+          <a:prstGeom prst="rect">
+            <a:avLst/>
+          </a:prstGeom>
+          <a:noFill/>
+        </p:spPr>
+        <p:txBody>
+          <a:bodyPr wrap="square" anchor="ctr" lIns="0" rIns="0" tIns="0" bIns="0">
+            <a:spAutoFit/>
+          </a:bodyPr>
+          <a:lstStyle/>
+          <a:p>
+            <a:pPr algn="r"/>
+            <a:r>
+              <a:rPr sz="1100" b="0" i="0">
+                <a:solidFill>
+                  <a:srgbClr val="5B5870"/>
+                </a:solidFill>
+                <a:latin typeface="Arial"/>
+              </a:rPr>
+              <a:t>17</a:t>
+            </a:r>
+          </a:p>
+        </p:txBody>
+      </p:sp>
+    </p:spTree>
+  </p:cSld>
+  <p:clrMapOvr>
+    <a:masterClrMapping/>
+  </p:clrMapOvr>
+</p:sld>
+</file>
+
+<file path=ppt/slides/slide18.xml><?xml version="1.0" encoding="utf-8"?>
+<p:sld xmlns:a="http://schemas.openxmlformats.org/drawingml/2006/main" xmlns:p="http://schemas.openxmlformats.org/presentationml/2006/main" xmlns:r="http://schemas.openxmlformats.org/officeDocument/2006/relationships">
+  <p:cSld>
+    <p:bg>
+      <p:bgPr>
+        <a:solidFill>
+          <a:srgbClr val="FFFFFF"/>
+        </a:solidFill>
+        <a:effectLst/>
+      </p:bgPr>
+    </p:bg>
+    <p:spTree>
+      <p:nvGrpSpPr>
+        <p:cNvPr id="1" name=""/>
+        <p:cNvGrpSpPr/>
+        <p:nvPr/>
+      </p:nvGrpSpPr>
+      <p:grpSpPr/>
+      <p:sp>
+        <p:nvSpPr>
+          <p:cNvPr id="2" name="Rectangle 1"/>
+          <p:cNvSpPr/>
+          <p:nvPr/>
+        </p:nvSpPr>
+        <p:spPr>
+          <a:xfrm>
+            <a:off x="0" y="0"/>
+            <a:ext cx="12191695" cy="6858000"/>
+          </a:xfrm>
+          <a:prstGeom prst="rect">
+            <a:avLst/>
+          </a:prstGeom>
+          <a:solidFill>
+            <a:srgbClr val="4A3AA7"/>
+          </a:solidFill>
+          <a:ln>
+            <a:noFill/>
+          </a:ln>
+          <a:effectLst/>
+        </p:spPr>
+        <p:style>
+          <a:lnRef idx="1">
+            <a:schemeClr val="accent1"/>
+          </a:lnRef>
+          <a:fillRef idx="3">
+            <a:schemeClr val="accent1"/>
+          </a:fillRef>
+          <a:effectRef idx="2">
+            <a:schemeClr val="accent1"/>
+          </a:effectRef>
+          <a:fontRef idx="minor">
+            <a:schemeClr val="lt1"/>
+          </a:fontRef>
+        </p:style>
+        <p:txBody>
+          <a:bodyPr rtlCol="0" anchor="ctr"/>
+          <a:lstStyle/>
+          <a:p>
+            <a:pPr algn="ctr"/>
+          </a:p>
+        </p:txBody>
+      </p:sp>
+      <p:sp>
+        <p:nvSpPr>
+          <p:cNvPr id="3" name="TextBox 2"/>
+          <p:cNvSpPr txBox="1"/>
+          <p:nvPr/>
+        </p:nvSpPr>
+        <p:spPr>
+          <a:xfrm>
             <a:off x="1051560" y="2103120"/>
             <a:ext cx="10500055" cy="1554480"/>
           </a:xfrm>
@@ -7606,7 +7813,7 @@
                 </a:solidFill>
                 <a:latin typeface="Arial"/>
               </a:rPr>
-              <a:t>16</a:t>
+              <a:t>18</a:t>
             </a:r>
           </a:p>
         </p:txBody>

</xml_diff>